<commit_message>
Remove outdated autograd notebook and update several PPT files, including modifications and new content.
</commit_message>
<xml_diff>
--- a/material/5_AI/09_회귀와경사하강법.pptx
+++ b/material/5_AI/09_회귀와경사하강법.pptx
@@ -5,7 +5,7 @@
     <p:sldMasterId id="2147483660" r:id="rId1"/>
   </p:sldMasterIdLst>
   <p:notesMasterIdLst>
-    <p:notesMasterId r:id="rId42"/>
+    <p:notesMasterId r:id="rId41"/>
   </p:notesMasterIdLst>
   <p:sldIdLst>
     <p:sldId id="1013" r:id="rId2"/>
@@ -46,8 +46,7 @@
     <p:sldId id="680" r:id="rId37"/>
     <p:sldId id="695" r:id="rId38"/>
     <p:sldId id="1007" r:id="rId39"/>
-    <p:sldId id="1016" r:id="rId40"/>
-    <p:sldId id="836" r:id="rId41"/>
+    <p:sldId id="836" r:id="rId40"/>
   </p:sldIdLst>
   <p:sldSz cx="12192000" cy="6858000"/>
   <p:notesSz cx="6858000" cy="9144000"/>
@@ -286,7 +285,7 @@
             <a:fld id="{A13A867C-D490-40C2-AB8D-A60FA70A9BF5}" type="datetimeFigureOut">
               <a:rPr lang="ko-KR" altLang="en-US" smtClean="0"/>
               <a:pPr/>
-              <a:t>2026-02-12</a:t>
+              <a:t>2026-02-13</a:t>
             </a:fld>
             <a:endParaRPr lang="ko-KR" altLang="en-US" dirty="0"/>
           </a:p>
@@ -1392,7 +1391,7 @@
           <a:p>
             <a:fld id="{A0085365-8376-4996-BDD6-F39608FADAF3}" type="slidenum">
               <a:rPr lang="ko-KR" altLang="en-US" smtClean="0"/>
-              <a:t>40</a:t>
+              <a:t>39</a:t>
             </a:fld>
             <a:endParaRPr lang="ko-KR" altLang="en-US"/>
           </a:p>
@@ -2403,7 +2402,7 @@
           <a:p>
             <a:fld id="{442BEE3F-2E9A-4FD8-8B8A-8619F3E161C0}" type="datetime1">
               <a:rPr lang="ko-KR" altLang="en-US" smtClean="0"/>
-              <a:t>2026-02-12</a:t>
+              <a:t>2026-02-13</a:t>
             </a:fld>
             <a:endParaRPr lang="ko-KR" altLang="en-US"/>
           </a:p>
@@ -2690,7 +2689,7 @@
           <a:p>
             <a:fld id="{0F78D9C4-20C1-4B15-A116-16DC77AD9A1E}" type="datetime1">
               <a:rPr lang="ko-KR" altLang="en-US" smtClean="0"/>
-              <a:t>2026-02-12</a:t>
+              <a:t>2026-02-13</a:t>
             </a:fld>
             <a:endParaRPr lang="ko-KR" altLang="en-US"/>
           </a:p>
@@ -2865,7 +2864,7 @@
           <a:p>
             <a:fld id="{7F5E23C3-0E3D-4E4E-8486-D7FB4C073DC1}" type="datetime1">
               <a:rPr lang="ko-KR" altLang="en-US" smtClean="0"/>
-              <a:t>2026-02-12</a:t>
+              <a:t>2026-02-13</a:t>
             </a:fld>
             <a:endParaRPr lang="ko-KR" altLang="en-US"/>
           </a:p>
@@ -3194,7 +3193,7 @@
           <a:p>
             <a:fld id="{7F5E23C3-0E3D-4E4E-8486-D7FB4C073DC1}" type="datetime1">
               <a:rPr lang="ko-KR" altLang="en-US" smtClean="0"/>
-              <a:t>2026-02-12</a:t>
+              <a:t>2026-02-13</a:t>
             </a:fld>
             <a:endParaRPr lang="ko-KR" altLang="en-US"/>
           </a:p>
@@ -4434,7 +4433,7 @@
           <a:p>
             <a:fld id="{0F78D9C4-20C1-4B15-A116-16DC77AD9A1E}" type="datetime1">
               <a:rPr lang="ko-KR" altLang="en-US" smtClean="0"/>
-              <a:t>2026-02-12</a:t>
+              <a:t>2026-02-13</a:t>
             </a:fld>
             <a:endParaRPr lang="ko-KR" altLang="en-US"/>
           </a:p>
@@ -4701,7 +4700,7 @@
           <a:p>
             <a:fld id="{0F78D9C4-20C1-4B15-A116-16DC77AD9A1E}" type="datetime1">
               <a:rPr lang="ko-KR" altLang="en-US" smtClean="0"/>
-              <a:t>2026-02-12</a:t>
+              <a:t>2026-02-13</a:t>
             </a:fld>
             <a:endParaRPr lang="ko-KR" altLang="en-US" dirty="0"/>
           </a:p>
@@ -5346,7 +5345,7 @@
           <a:p>
             <a:fld id="{0F78D9C4-20C1-4B15-A116-16DC77AD9A1E}" type="datetime1">
               <a:rPr lang="ko-KR" altLang="en-US" smtClean="0"/>
-              <a:t>2026-02-12</a:t>
+              <a:t>2026-02-13</a:t>
             </a:fld>
             <a:endParaRPr lang="ko-KR" altLang="en-US"/>
           </a:p>
@@ -5524,7 +5523,7 @@
           <a:p>
             <a:fld id="{0F78D9C4-20C1-4B15-A116-16DC77AD9A1E}" type="datetime1">
               <a:rPr lang="ko-KR" altLang="en-US" smtClean="0"/>
-              <a:t>2026-02-12</a:t>
+              <a:t>2026-02-13</a:t>
             </a:fld>
             <a:endParaRPr lang="ko-KR" altLang="en-US"/>
           </a:p>
@@ -6470,7 +6469,7 @@
           <a:p>
             <a:fld id="{0F78D9C4-20C1-4B15-A116-16DC77AD9A1E}" type="datetime1">
               <a:rPr lang="ko-KR" altLang="en-US" smtClean="0"/>
-              <a:t>2026-02-12</a:t>
+              <a:t>2026-02-13</a:t>
             </a:fld>
             <a:endParaRPr lang="ko-KR" altLang="en-US"/>
           </a:p>
@@ -6648,7 +6647,7 @@
           <a:p>
             <a:fld id="{0F78D9C4-20C1-4B15-A116-16DC77AD9A1E}" type="datetime1">
               <a:rPr lang="ko-KR" altLang="en-US" smtClean="0"/>
-              <a:t>2026-02-12</a:t>
+              <a:t>2026-02-13</a:t>
             </a:fld>
             <a:endParaRPr lang="ko-KR" altLang="en-US"/>
           </a:p>
@@ -7737,7 +7736,7 @@
           <a:p>
             <a:fld id="{0F78D9C4-20C1-4B15-A116-16DC77AD9A1E}" type="datetime1">
               <a:rPr lang="ko-KR" altLang="en-US" smtClean="0"/>
-              <a:t>2026-02-12</a:t>
+              <a:t>2026-02-13</a:t>
             </a:fld>
             <a:endParaRPr lang="ko-KR" altLang="en-US"/>
           </a:p>
@@ -8109,7 +8108,7 @@
           <a:p>
             <a:fld id="{0F78D9C4-20C1-4B15-A116-16DC77AD9A1E}" type="datetime1">
               <a:rPr lang="ko-KR" altLang="en-US" smtClean="0"/>
-              <a:t>2026-02-12</a:t>
+              <a:t>2026-02-13</a:t>
             </a:fld>
             <a:endParaRPr lang="ko-KR" altLang="en-US"/>
           </a:p>
@@ -8322,7 +8321,7 @@
           <a:p>
             <a:fld id="{0F78D9C4-20C1-4B15-A116-16DC77AD9A1E}" type="datetime1">
               <a:rPr lang="ko-KR" altLang="en-US" smtClean="0"/>
-              <a:t>2026-02-12</a:t>
+              <a:t>2026-02-13</a:t>
             </a:fld>
             <a:endParaRPr lang="ko-KR" altLang="en-US"/>
           </a:p>
@@ -8842,7 +8841,7 @@
           <a:p>
             <a:fld id="{0F78D9C4-20C1-4B15-A116-16DC77AD9A1E}" type="datetime1">
               <a:rPr lang="ko-KR" altLang="en-US" smtClean="0"/>
-              <a:t>2026-02-12</a:t>
+              <a:t>2026-02-13</a:t>
             </a:fld>
             <a:endParaRPr lang="ko-KR" altLang="en-US"/>
           </a:p>
@@ -10721,7 +10720,7 @@
           <a:p>
             <a:fld id="{0F78D9C4-20C1-4B15-A116-16DC77AD9A1E}" type="datetime1">
               <a:rPr lang="ko-KR" altLang="en-US" smtClean="0"/>
-              <a:t>2026-02-12</a:t>
+              <a:t>2026-02-13</a:t>
             </a:fld>
             <a:endParaRPr lang="ko-KR" altLang="en-US"/>
           </a:p>
@@ -11105,7 +11104,7 @@
           <a:p>
             <a:fld id="{0F78D9C4-20C1-4B15-A116-16DC77AD9A1E}" type="datetime1">
               <a:rPr lang="ko-KR" altLang="en-US" smtClean="0"/>
-              <a:t>2026-02-12</a:t>
+              <a:t>2026-02-13</a:t>
             </a:fld>
             <a:endParaRPr lang="ko-KR" altLang="en-US"/>
           </a:p>
@@ -11501,7 +11500,7 @@
           <a:p>
             <a:fld id="{0F78D9C4-20C1-4B15-A116-16DC77AD9A1E}" type="datetime1">
               <a:rPr lang="ko-KR" altLang="en-US" smtClean="0"/>
-              <a:t>2026-02-12</a:t>
+              <a:t>2026-02-13</a:t>
             </a:fld>
             <a:endParaRPr lang="ko-KR" altLang="en-US"/>
           </a:p>
@@ -12015,7 +12014,7 @@
           <a:p>
             <a:fld id="{0F78D9C4-20C1-4B15-A116-16DC77AD9A1E}" type="datetime1">
               <a:rPr lang="ko-KR" altLang="en-US" smtClean="0"/>
-              <a:t>2026-02-12</a:t>
+              <a:t>2026-02-13</a:t>
             </a:fld>
             <a:endParaRPr lang="ko-KR" altLang="en-US"/>
           </a:p>
@@ -12214,7 +12213,7 @@
           <a:p>
             <a:fld id="{0F78D9C4-20C1-4B15-A116-16DC77AD9A1E}" type="datetime1">
               <a:rPr lang="ko-KR" altLang="en-US" smtClean="0"/>
-              <a:t>2026-02-12</a:t>
+              <a:t>2026-02-13</a:t>
             </a:fld>
             <a:endParaRPr lang="ko-KR" altLang="en-US"/>
           </a:p>
@@ -12500,7 +12499,7 @@
           <a:p>
             <a:fld id="{0F78D9C4-20C1-4B15-A116-16DC77AD9A1E}" type="datetime1">
               <a:rPr lang="ko-KR" altLang="en-US" smtClean="0"/>
-              <a:t>2026-02-12</a:t>
+              <a:t>2026-02-13</a:t>
             </a:fld>
             <a:endParaRPr lang="ko-KR" altLang="en-US"/>
           </a:p>
@@ -12907,7 +12906,7 @@
           <a:p>
             <a:fld id="{0F78D9C4-20C1-4B15-A116-16DC77AD9A1E}" type="datetime1">
               <a:rPr lang="ko-KR" altLang="en-US" smtClean="0"/>
-              <a:t>2026-02-12</a:t>
+              <a:t>2026-02-13</a:t>
             </a:fld>
             <a:endParaRPr lang="ko-KR" altLang="en-US" dirty="0"/>
           </a:p>
@@ -13305,7 +13304,7 @@
           <a:p>
             <a:fld id="{0F78D9C4-20C1-4B15-A116-16DC77AD9A1E}" type="datetime1">
               <a:rPr lang="ko-KR" altLang="en-US" smtClean="0"/>
-              <a:t>2026-02-12</a:t>
+              <a:t>2026-02-13</a:t>
             </a:fld>
             <a:endParaRPr lang="ko-KR" altLang="en-US"/>
           </a:p>
@@ -13708,7 +13707,7 @@
           <a:p>
             <a:fld id="{0F78D9C4-20C1-4B15-A116-16DC77AD9A1E}" type="datetime1">
               <a:rPr lang="ko-KR" altLang="en-US" smtClean="0"/>
-              <a:t>2026-02-12</a:t>
+              <a:t>2026-02-13</a:t>
             </a:fld>
             <a:endParaRPr lang="ko-KR" altLang="en-US"/>
           </a:p>
@@ -13827,7 +13826,7 @@
           <a:p>
             <a:fld id="{0F78D9C4-20C1-4B15-A116-16DC77AD9A1E}" type="datetime1">
               <a:rPr lang="ko-KR" altLang="en-US" smtClean="0"/>
-              <a:t>2026-02-12</a:t>
+              <a:t>2026-02-13</a:t>
             </a:fld>
             <a:endParaRPr lang="ko-KR" altLang="en-US"/>
           </a:p>
@@ -14157,7 +14156,7 @@
           <a:p>
             <a:fld id="{0F78D9C4-20C1-4B15-A116-16DC77AD9A1E}" type="datetime1">
               <a:rPr lang="ko-KR" altLang="en-US" smtClean="0"/>
-              <a:t>2026-02-12</a:t>
+              <a:t>2026-02-13</a:t>
             </a:fld>
             <a:endParaRPr lang="ko-KR" altLang="en-US"/>
           </a:p>
@@ -15929,7 +15928,7 @@
           <a:p>
             <a:fld id="{0F78D9C4-20C1-4B15-A116-16DC77AD9A1E}" type="datetime1">
               <a:rPr lang="ko-KR" altLang="en-US" smtClean="0"/>
-              <a:t>2026-02-12</a:t>
+              <a:t>2026-02-13</a:t>
             </a:fld>
             <a:endParaRPr lang="ko-KR" altLang="en-US"/>
           </a:p>
@@ -16275,7 +16274,7 @@
           <a:p>
             <a:fld id="{0F78D9C4-20C1-4B15-A116-16DC77AD9A1E}" type="datetime1">
               <a:rPr lang="ko-KR" altLang="en-US" smtClean="0"/>
-              <a:t>2026-02-12</a:t>
+              <a:t>2026-02-13</a:t>
             </a:fld>
             <a:endParaRPr lang="ko-KR" altLang="en-US"/>
           </a:p>
@@ -16700,7 +16699,7 @@
           <a:p>
             <a:fld id="{0F78D9C4-20C1-4B15-A116-16DC77AD9A1E}" type="datetime1">
               <a:rPr lang="ko-KR" altLang="en-US" smtClean="0"/>
-              <a:t>2026-02-12</a:t>
+              <a:t>2026-02-13</a:t>
             </a:fld>
             <a:endParaRPr lang="ko-KR" altLang="en-US"/>
           </a:p>
@@ -16831,7 +16830,7 @@
           <a:p>
             <a:fld id="{0F78D9C4-20C1-4B15-A116-16DC77AD9A1E}" type="datetime1">
               <a:rPr lang="ko-KR" altLang="en-US" smtClean="0"/>
-              <a:t>2026-02-12</a:t>
+              <a:t>2026-02-13</a:t>
             </a:fld>
             <a:endParaRPr lang="ko-KR" altLang="en-US"/>
           </a:p>
@@ -17440,7 +17439,7 @@
           <a:p>
             <a:fld id="{0F78D9C4-20C1-4B15-A116-16DC77AD9A1E}" type="datetime1">
               <a:rPr lang="ko-KR" altLang="en-US" smtClean="0"/>
-              <a:t>2026-02-12</a:t>
+              <a:t>2026-02-13</a:t>
             </a:fld>
             <a:endParaRPr lang="ko-KR" altLang="en-US"/>
           </a:p>
@@ -17573,7 +17572,7 @@
           <a:p>
             <a:fld id="{0F78D9C4-20C1-4B15-A116-16DC77AD9A1E}" type="datetime1">
               <a:rPr lang="ko-KR" altLang="en-US" smtClean="0"/>
-              <a:t>2026-02-12</a:t>
+              <a:t>2026-02-13</a:t>
             </a:fld>
             <a:endParaRPr lang="ko-KR" altLang="en-US"/>
           </a:p>
@@ -17978,7 +17977,7 @@
           <a:p>
             <a:fld id="{0F78D9C4-20C1-4B15-A116-16DC77AD9A1E}" type="datetime1">
               <a:rPr lang="ko-KR" altLang="en-US" smtClean="0"/>
-              <a:t>2026-02-12</a:t>
+              <a:t>2026-02-13</a:t>
             </a:fld>
             <a:endParaRPr lang="ko-KR" altLang="en-US"/>
           </a:p>
@@ -18286,7 +18285,7 @@
           <a:p>
             <a:fld id="{0F78D9C4-20C1-4B15-A116-16DC77AD9A1E}" type="datetime1">
               <a:rPr lang="ko-KR" altLang="en-US" smtClean="0"/>
-              <a:t>2026-02-12</a:t>
+              <a:t>2026-02-13</a:t>
             </a:fld>
             <a:endParaRPr lang="ko-KR" altLang="en-US"/>
           </a:p>
@@ -18434,7 +18433,13 @@
   <p:cSld>
     <p:spTree>
       <p:nvGrpSpPr>
-        <p:cNvPr id="1" name=""/>
+        <p:cNvPr id="1" name="">
+          <a:extLst>
+            <a:ext uri="{FF2B5EF4-FFF2-40B4-BE49-F238E27FC236}">
+              <a16:creationId xmlns:a16="http://schemas.microsoft.com/office/drawing/2014/main" id="{B7171936-481C-71EB-7D96-6C9DFC6F979D}"/>
+            </a:ext>
+          </a:extLst>
+        </p:cNvPr>
         <p:cNvGrpSpPr/>
         <p:nvPr/>
       </p:nvGrpSpPr>
@@ -18448,73 +18453,68 @@
       </p:grpSpPr>
       <p:sp>
         <p:nvSpPr>
-          <p:cNvPr id="2" name="제목 1">
+          <p:cNvPr id="4" name="제목 1">
             <a:extLst>
               <a:ext uri="{FF2B5EF4-FFF2-40B4-BE49-F238E27FC236}">
-                <a16:creationId xmlns:a16="http://schemas.microsoft.com/office/drawing/2014/main" id="{FC0A2AB7-4D5E-6614-0E8C-D87C787D466A}"/>
+                <a16:creationId xmlns:a16="http://schemas.microsoft.com/office/drawing/2014/main" id="{100005ED-53E3-BFC8-AFAA-7BAFFA3752AB}"/>
               </a:ext>
             </a:extLst>
           </p:cNvPr>
-          <p:cNvSpPr>
-            <a:spLocks noGrp="1"/>
+          <p:cNvSpPr txBox="1">
+            <a:spLocks/>
           </p:cNvSpPr>
-          <p:nvPr>
-            <p:ph type="title"/>
-          </p:nvPr>
+          <p:nvPr/>
         </p:nvSpPr>
-        <p:spPr/>
+        <p:spPr>
+          <a:xfrm>
+            <a:off x="1524000" y="2555530"/>
+            <a:ext cx="9144000" cy="1116107"/>
+          </a:xfrm>
+          <a:prstGeom prst="rect">
+            <a:avLst/>
+          </a:prstGeom>
+        </p:spPr>
         <p:txBody>
-          <a:bodyPr/>
-          <a:lstStyle/>
-          <a:p>
-            <a:r>
-              <a:rPr lang="ko-KR" altLang="en-US" dirty="0"/>
-              <a:t>실습</a:t>
-            </a:r>
-            <a:r>
-              <a:rPr lang="en-US" altLang="ko-KR" dirty="0"/>
-              <a:t>1. </a:t>
-            </a:r>
-            <a:r>
-              <a:rPr lang="ko-KR" altLang="en-US" dirty="0" err="1"/>
-              <a:t>경사하강법</a:t>
-            </a:r>
-            <a:r>
-              <a:rPr lang="ko-KR" altLang="en-US"/>
-              <a:t> 구현</a:t>
-            </a:r>
-          </a:p>
-        </p:txBody>
-      </p:sp>
-      <p:sp>
-        <p:nvSpPr>
-          <p:cNvPr id="3" name="내용 개체 틀 2">
-            <a:extLst>
-              <a:ext uri="{FF2B5EF4-FFF2-40B4-BE49-F238E27FC236}">
-                <a16:creationId xmlns:a16="http://schemas.microsoft.com/office/drawing/2014/main" id="{CFE2628F-1AD1-7A7C-57EC-83570A962913}"/>
-              </a:ext>
-            </a:extLst>
-          </p:cNvPr>
-          <p:cNvSpPr>
-            <a:spLocks noGrp="1"/>
-          </p:cNvSpPr>
-          <p:nvPr>
-            <p:ph idx="1"/>
-          </p:nvPr>
-        </p:nvSpPr>
-        <p:spPr/>
-        <p:txBody>
-          <a:bodyPr/>
-          <a:lstStyle/>
-          <a:p>
-            <a:endParaRPr lang="ko-KR" altLang="en-US"/>
+          <a:bodyPr vert="horz" lIns="91440" tIns="45720" rIns="91440" bIns="45720" rtlCol="0" anchor="b">
+            <a:normAutofit/>
+          </a:bodyPr>
+          <a:lstStyle>
+            <a:lvl1pPr algn="ctr" defTabSz="914400" rtl="0" eaLnBrk="1" latinLnBrk="1" hangingPunct="1">
+              <a:lnSpc>
+                <a:spcPct val="90000"/>
+              </a:lnSpc>
+              <a:spcBef>
+                <a:spcPct val="0"/>
+              </a:spcBef>
+              <a:buNone/>
+              <a:defRPr sz="6000" kern="1200">
+                <a:solidFill>
+                  <a:schemeClr val="tx1"/>
+                </a:solidFill>
+                <a:latin typeface="+mj-lt"/>
+                <a:ea typeface="+mj-ea"/>
+                <a:cs typeface="+mj-cs"/>
+              </a:defRPr>
+            </a:lvl1pPr>
+          </a:lstStyle>
+          <a:p>
+            <a:r>
+              <a:rPr lang="ko-KR" altLang="en-US" dirty="0">
+                <a:solidFill>
+                  <a:schemeClr val="accent2"/>
+                </a:solidFill>
+                <a:latin typeface="G마켓 산스 TTF Bold" panose="02000000000000000000" pitchFamily="2" charset="-127"/>
+                <a:ea typeface="G마켓 산스 TTF Bold" panose="02000000000000000000" pitchFamily="2" charset="-127"/>
+              </a:rPr>
+              <a:t>감사합니다</a:t>
+            </a:r>
           </a:p>
         </p:txBody>
       </p:sp>
     </p:spTree>
     <p:extLst>
       <p:ext uri="{BB962C8B-B14F-4D97-AF65-F5344CB8AC3E}">
-        <p14:creationId xmlns:p14="http://schemas.microsoft.com/office/powerpoint/2010/main" val="3539734480"/>
+        <p14:creationId xmlns:p14="http://schemas.microsoft.com/office/powerpoint/2010/main" val="4171818688"/>
       </p:ext>
     </p:extLst>
   </p:cSld>
@@ -18823,7 +18823,7 @@
           <a:p>
             <a:fld id="{0F78D9C4-20C1-4B15-A116-16DC77AD9A1E}" type="datetime1">
               <a:rPr lang="ko-KR" altLang="en-US" smtClean="0"/>
-              <a:t>2026-02-12</a:t>
+              <a:t>2026-02-13</a:t>
             </a:fld>
             <a:endParaRPr lang="ko-KR" altLang="en-US"/>
           </a:p>
@@ -18899,102 +18899,6 @@
     <p:extLst>
       <p:ext uri="{BB962C8B-B14F-4D97-AF65-F5344CB8AC3E}">
         <p14:creationId xmlns:p14="http://schemas.microsoft.com/office/powerpoint/2010/main" val="1915908932"/>
-      </p:ext>
-    </p:extLst>
-  </p:cSld>
-  <p:clrMapOvr>
-    <a:masterClrMapping/>
-  </p:clrMapOvr>
-</p:sld>
-</file>
-
-<file path=ppt/slides/slide40.xml><?xml version="1.0" encoding="utf-8"?>
-<p:sld xmlns:a="http://schemas.openxmlformats.org/drawingml/2006/main" xmlns:r="http://schemas.openxmlformats.org/officeDocument/2006/relationships" xmlns:p="http://schemas.openxmlformats.org/presentationml/2006/main">
-  <p:cSld>
-    <p:spTree>
-      <p:nvGrpSpPr>
-        <p:cNvPr id="1" name="">
-          <a:extLst>
-            <a:ext uri="{FF2B5EF4-FFF2-40B4-BE49-F238E27FC236}">
-              <a16:creationId xmlns:a16="http://schemas.microsoft.com/office/drawing/2014/main" id="{B7171936-481C-71EB-7D96-6C9DFC6F979D}"/>
-            </a:ext>
-          </a:extLst>
-        </p:cNvPr>
-        <p:cNvGrpSpPr/>
-        <p:nvPr/>
-      </p:nvGrpSpPr>
-      <p:grpSpPr>
-        <a:xfrm>
-          <a:off x="0" y="0"/>
-          <a:ext cx="0" cy="0"/>
-          <a:chOff x="0" y="0"/>
-          <a:chExt cx="0" cy="0"/>
-        </a:xfrm>
-      </p:grpSpPr>
-      <p:sp>
-        <p:nvSpPr>
-          <p:cNvPr id="4" name="제목 1">
-            <a:extLst>
-              <a:ext uri="{FF2B5EF4-FFF2-40B4-BE49-F238E27FC236}">
-                <a16:creationId xmlns:a16="http://schemas.microsoft.com/office/drawing/2014/main" id="{100005ED-53E3-BFC8-AFAA-7BAFFA3752AB}"/>
-              </a:ext>
-            </a:extLst>
-          </p:cNvPr>
-          <p:cNvSpPr txBox="1">
-            <a:spLocks/>
-          </p:cNvSpPr>
-          <p:nvPr/>
-        </p:nvSpPr>
-        <p:spPr>
-          <a:xfrm>
-            <a:off x="1524000" y="2555530"/>
-            <a:ext cx="9144000" cy="1116107"/>
-          </a:xfrm>
-          <a:prstGeom prst="rect">
-            <a:avLst/>
-          </a:prstGeom>
-        </p:spPr>
-        <p:txBody>
-          <a:bodyPr vert="horz" lIns="91440" tIns="45720" rIns="91440" bIns="45720" rtlCol="0" anchor="b">
-            <a:normAutofit/>
-          </a:bodyPr>
-          <a:lstStyle>
-            <a:lvl1pPr algn="ctr" defTabSz="914400" rtl="0" eaLnBrk="1" latinLnBrk="1" hangingPunct="1">
-              <a:lnSpc>
-                <a:spcPct val="90000"/>
-              </a:lnSpc>
-              <a:spcBef>
-                <a:spcPct val="0"/>
-              </a:spcBef>
-              <a:buNone/>
-              <a:defRPr sz="6000" kern="1200">
-                <a:solidFill>
-                  <a:schemeClr val="tx1"/>
-                </a:solidFill>
-                <a:latin typeface="+mj-lt"/>
-                <a:ea typeface="+mj-ea"/>
-                <a:cs typeface="+mj-cs"/>
-              </a:defRPr>
-            </a:lvl1pPr>
-          </a:lstStyle>
-          <a:p>
-            <a:r>
-              <a:rPr lang="ko-KR" altLang="en-US" dirty="0">
-                <a:solidFill>
-                  <a:schemeClr val="accent2"/>
-                </a:solidFill>
-                <a:latin typeface="G마켓 산스 TTF Bold" panose="02000000000000000000" pitchFamily="2" charset="-127"/>
-                <a:ea typeface="G마켓 산스 TTF Bold" panose="02000000000000000000" pitchFamily="2" charset="-127"/>
-              </a:rPr>
-              <a:t>감사합니다</a:t>
-            </a:r>
-          </a:p>
-        </p:txBody>
-      </p:sp>
-    </p:spTree>
-    <p:extLst>
-      <p:ext uri="{BB962C8B-B14F-4D97-AF65-F5344CB8AC3E}">
-        <p14:creationId xmlns:p14="http://schemas.microsoft.com/office/powerpoint/2010/main" val="4171818688"/>
       </p:ext>
     </p:extLst>
   </p:cSld>
@@ -19050,7 +18954,7 @@
           <a:p>
             <a:fld id="{0F78D9C4-20C1-4B15-A116-16DC77AD9A1E}" type="datetime1">
               <a:rPr lang="ko-KR" altLang="en-US" smtClean="0"/>
-              <a:t>2026-02-12</a:t>
+              <a:t>2026-02-13</a:t>
             </a:fld>
             <a:endParaRPr lang="ko-KR" altLang="en-US"/>
           </a:p>
@@ -19537,7 +19441,7 @@
           <a:p>
             <a:fld id="{0F78D9C4-20C1-4B15-A116-16DC77AD9A1E}" type="datetime1">
               <a:rPr lang="ko-KR" altLang="en-US" smtClean="0"/>
-              <a:t>2026-02-12</a:t>
+              <a:t>2026-02-13</a:t>
             </a:fld>
             <a:endParaRPr lang="ko-KR" altLang="en-US"/>
           </a:p>
@@ -20181,7 +20085,7 @@
           <a:p>
             <a:fld id="{0F78D9C4-20C1-4B15-A116-16DC77AD9A1E}" type="datetime1">
               <a:rPr lang="ko-KR" altLang="en-US" smtClean="0"/>
-              <a:t>2026-02-12</a:t>
+              <a:t>2026-02-13</a:t>
             </a:fld>
             <a:endParaRPr lang="ko-KR" altLang="en-US"/>
           </a:p>
@@ -20476,7 +20380,7 @@
           <a:p>
             <a:fld id="{0F78D9C4-20C1-4B15-A116-16DC77AD9A1E}" type="datetime1">
               <a:rPr lang="ko-KR" altLang="en-US" smtClean="0"/>
-              <a:t>2026-02-12</a:t>
+              <a:t>2026-02-13</a:t>
             </a:fld>
             <a:endParaRPr lang="ko-KR" altLang="en-US"/>
           </a:p>
@@ -23751,7 +23655,7 @@
           <a:p>
             <a:fld id="{0F78D9C4-20C1-4B15-A116-16DC77AD9A1E}" type="datetime1">
               <a:rPr lang="ko-KR" altLang="en-US" smtClean="0"/>
-              <a:t>2026-02-12</a:t>
+              <a:t>2026-02-13</a:t>
             </a:fld>
             <a:endParaRPr lang="ko-KR" altLang="en-US"/>
           </a:p>

</xml_diff>